<commit_message>
add sponsors in presentation template
</commit_message>
<xml_diff>
--- a/public/templates/Plantilla_SIQUI.pptx
+++ b/public/templates/Plantilla_SIQUI.pptx
@@ -328,7 +328,7 @@
             <a:fld id="{1D8BD707-D9CF-40AE-B4C6-C98DA3205C09}" type="datetimeFigureOut">
               <a:rPr lang="en-US" smtClean="0"/>
               <a:pPr/>
-              <a:t>9/17/2025</a:t>
+              <a:t>9/26/2025</a:t>
             </a:fld>
             <a:endParaRPr lang="en-US"/>
           </a:p>
@@ -493,7 +493,7 @@
             <a:fld id="{1D8BD707-D9CF-40AE-B4C6-C98DA3205C09}" type="datetimeFigureOut">
               <a:rPr lang="en-US" smtClean="0"/>
               <a:pPr/>
-              <a:t>9/17/2025</a:t>
+              <a:t>9/26/2025</a:t>
             </a:fld>
             <a:endParaRPr lang="en-US"/>
           </a:p>
@@ -668,7 +668,7 @@
             <a:fld id="{1D8BD707-D9CF-40AE-B4C6-C98DA3205C09}" type="datetimeFigureOut">
               <a:rPr lang="en-US" smtClean="0"/>
               <a:pPr/>
-              <a:t>9/17/2025</a:t>
+              <a:t>9/26/2025</a:t>
             </a:fld>
             <a:endParaRPr lang="en-US"/>
           </a:p>
@@ -833,7 +833,7 @@
             <a:fld id="{1D8BD707-D9CF-40AE-B4C6-C98DA3205C09}" type="datetimeFigureOut">
               <a:rPr lang="en-US" smtClean="0"/>
               <a:pPr/>
-              <a:t>9/17/2025</a:t>
+              <a:t>9/26/2025</a:t>
             </a:fld>
             <a:endParaRPr lang="en-US"/>
           </a:p>
@@ -1075,7 +1075,7 @@
             <a:fld id="{1D8BD707-D9CF-40AE-B4C6-C98DA3205C09}" type="datetimeFigureOut">
               <a:rPr lang="en-US" smtClean="0"/>
               <a:pPr/>
-              <a:t>9/17/2025</a:t>
+              <a:t>9/26/2025</a:t>
             </a:fld>
             <a:endParaRPr lang="en-US"/>
           </a:p>
@@ -1357,7 +1357,7 @@
             <a:fld id="{1D8BD707-D9CF-40AE-B4C6-C98DA3205C09}" type="datetimeFigureOut">
               <a:rPr lang="en-US" smtClean="0"/>
               <a:pPr/>
-              <a:t>9/17/2025</a:t>
+              <a:t>9/26/2025</a:t>
             </a:fld>
             <a:endParaRPr lang="en-US"/>
           </a:p>
@@ -1773,7 +1773,7 @@
             <a:fld id="{1D8BD707-D9CF-40AE-B4C6-C98DA3205C09}" type="datetimeFigureOut">
               <a:rPr lang="en-US" smtClean="0"/>
               <a:pPr/>
-              <a:t>9/17/2025</a:t>
+              <a:t>9/26/2025</a:t>
             </a:fld>
             <a:endParaRPr lang="en-US"/>
           </a:p>
@@ -1887,7 +1887,7 @@
             <a:fld id="{1D8BD707-D9CF-40AE-B4C6-C98DA3205C09}" type="datetimeFigureOut">
               <a:rPr lang="en-US" smtClean="0"/>
               <a:pPr/>
-              <a:t>9/17/2025</a:t>
+              <a:t>9/26/2025</a:t>
             </a:fld>
             <a:endParaRPr lang="en-US"/>
           </a:p>
@@ -1979,7 +1979,7 @@
             <a:fld id="{1D8BD707-D9CF-40AE-B4C6-C98DA3205C09}" type="datetimeFigureOut">
               <a:rPr lang="en-US" smtClean="0"/>
               <a:pPr/>
-              <a:t>9/17/2025</a:t>
+              <a:t>9/26/2025</a:t>
             </a:fld>
             <a:endParaRPr lang="en-US"/>
           </a:p>
@@ -2251,7 +2251,7 @@
             <a:fld id="{1D8BD707-D9CF-40AE-B4C6-C98DA3205C09}" type="datetimeFigureOut">
               <a:rPr lang="en-US" smtClean="0"/>
               <a:pPr/>
-              <a:t>9/17/2025</a:t>
+              <a:t>9/26/2025</a:t>
             </a:fld>
             <a:endParaRPr lang="en-US"/>
           </a:p>
@@ -2500,7 +2500,7 @@
             <a:fld id="{1D8BD707-D9CF-40AE-B4C6-C98DA3205C09}" type="datetimeFigureOut">
               <a:rPr lang="en-US" smtClean="0"/>
               <a:pPr/>
-              <a:t>9/17/2025</a:t>
+              <a:t>9/26/2025</a:t>
             </a:fld>
             <a:endParaRPr lang="en-US"/>
           </a:p>
@@ -2708,7 +2708,7 @@
             <a:fld id="{1D8BD707-D9CF-40AE-B4C6-C98DA3205C09}" type="datetimeFigureOut">
               <a:rPr lang="en-US" smtClean="0"/>
               <a:pPr/>
-              <a:t>9/17/2025</a:t>
+              <a:t>9/26/2025</a:t>
             </a:fld>
             <a:endParaRPr lang="en-US"/>
           </a:p>
@@ -3956,7 +3956,7 @@
               </a:lnSpc>
             </a:pPr>
             <a:r>
-              <a:rPr lang="en-US" sz="8100" b="1" spc="-38">
+              <a:rPr lang="en-US" sz="8100" b="1" spc="-38" dirty="0" err="1">
                 <a:solidFill>
                   <a:srgbClr val="9E9C9D"/>
                 </a:solidFill>
@@ -3967,6 +3967,15 @@
               </a:rPr>
               <a:t>Agradecimientos</a:t>
             </a:r>
+            <a:endParaRPr lang="en-US" sz="8100" b="1" spc="-38" dirty="0">
+              <a:solidFill>
+                <a:srgbClr val="9E9C9D"/>
+              </a:solidFill>
+              <a:latin typeface="Open Sans 1 Bold"/>
+              <a:ea typeface="Open Sans 1 Bold"/>
+              <a:cs typeface="Open Sans 1 Bold"/>
+              <a:sym typeface="Open Sans 1 Bold"/>
+            </a:endParaRPr>
           </a:p>
         </p:txBody>
       </p:sp>

</xml_diff>